<commit_message>
Fix mistakes in invoice generator documents
</commit_message>
<xml_diff>
--- a/ENIGMAS/INVOICE_GENERATOR/Required_Doc/automatic invoice ppt.pptx
+++ b/ENIGMAS/INVOICE_GENERATOR/Required_Doc/automatic invoice ppt.pptx
@@ -120,6 +120,11 @@
       </a:defRPr>
     </a:lvl9pPr>
   </p:defaultTextStyle>
+  <p:extLst>
+    <p:ext uri="{EFAFB233-063F-42B5-8137-9DF3F51BA10A}">
+      <p15:sldGuideLst xmlns:p15="http://schemas.microsoft.com/office/powerpoint/2012/main"/>
+    </p:ext>
+  </p:extLst>
 </p:presentation>
 </file>
 
@@ -136,10 +141,25 @@
   <pc:docChgLst>
     <pc:chgData name="chaitali patil" userId="93c03ccf1d40b7ec" providerId="LiveId" clId="{12F2214F-EB89-498D-9B46-BFD7F3C920F7}"/>
     <pc:docChg chg="custSel addSld modSld">
-      <pc:chgData name="chaitali patil" userId="93c03ccf1d40b7ec" providerId="LiveId" clId="{12F2214F-EB89-498D-9B46-BFD7F3C920F7}" dt="2026-07-12T23:09:13.708" v="581" actId="14100"/>
+      <pc:chgData name="chaitali patil" userId="93c03ccf1d40b7ec" providerId="LiveId" clId="{12F2214F-EB89-498D-9B46-BFD7F3C920F7}" dt="2026-07-13T00:22:00.279" v="614" actId="20577"/>
       <pc:docMkLst>
         <pc:docMk/>
       </pc:docMkLst>
+      <pc:sldChg chg="modSp mod">
+        <pc:chgData name="chaitali patil" userId="93c03ccf1d40b7ec" providerId="LiveId" clId="{12F2214F-EB89-498D-9B46-BFD7F3C920F7}" dt="2026-07-13T00:22:00.279" v="614" actId="20577"/>
+        <pc:sldMkLst>
+          <pc:docMk/>
+          <pc:sldMk cId="1134574598" sldId="256"/>
+        </pc:sldMkLst>
+        <pc:spChg chg="mod">
+          <ac:chgData name="chaitali patil" userId="93c03ccf1d40b7ec" providerId="LiveId" clId="{12F2214F-EB89-498D-9B46-BFD7F3C920F7}" dt="2026-07-13T00:22:00.279" v="614" actId="20577"/>
+          <ac:spMkLst>
+            <pc:docMk/>
+            <pc:sldMk cId="1134574598" sldId="256"/>
+            <ac:spMk id="3" creationId="{BCAA14C4-E550-FDB7-7383-4DACEA075776}"/>
+          </ac:spMkLst>
+        </pc:spChg>
+      </pc:sldChg>
       <pc:sldChg chg="modSp mod">
         <pc:chgData name="chaitali patil" userId="93c03ccf1d40b7ec" providerId="LiveId" clId="{12F2214F-EB89-498D-9B46-BFD7F3C920F7}" dt="2026-07-12T22:49:27.631" v="235" actId="20577"/>
         <pc:sldMkLst>
@@ -3471,16 +3491,17 @@
           <a:p>
             <a:r>
               <a:rPr lang="en-IN" sz="3200" dirty="0"/>
-              <a:t>Team name :- </a:t>
-            </a:r>
-            <a:r>
-              <a:rPr lang="en-IN" sz="3200" dirty="0" err="1"/>
-              <a:t>TrailBlazers</a:t>
-            </a:r>
-            <a:r>
-              <a:rPr lang="en-IN" dirty="0"/>
+              <a:t>Team name </a:t>
+            </a:r>
+            <a:r>
+              <a:rPr lang="en-IN" sz="3200"/>
+              <a:t>:- Enigmas</a:t>
+            </a:r>
+            <a:r>
+              <a:rPr lang="en-IN"/>
               <a:t>.</a:t>
             </a:r>
+            <a:endParaRPr lang="en-IN" dirty="0"/>
           </a:p>
         </p:txBody>
       </p:sp>

</xml_diff>

<commit_message>
Update invoice generator documentation files
</commit_message>
<xml_diff>
--- a/ENIGMAS/INVOICE_GENERATOR/Required_Doc/automatic invoice ppt.pptx
+++ b/ENIGMAS/INVOICE_GENERATOR/Required_Doc/automatic invoice ppt.pptx
@@ -131,7 +131,7 @@
 <file path=ppt/revisionInfo.xml><?xml version="1.0" encoding="utf-8"?>
 <p1510:revInfo xmlns:a="http://schemas.openxmlformats.org/drawingml/2006/main" xmlns:r="http://schemas.openxmlformats.org/officeDocument/2006/relationships" xmlns:p1510="http://schemas.microsoft.com/office/powerpoint/2015/10/main">
   <p1510:revLst>
-    <p1510:client id="{D290BC1B-6CCA-4432-9DE2-91F55AFBD6FC}" v="1" dt="2026-07-12T23:07:43.947"/>
+    <p1510:client id="{E21096E9-E2B7-4049-B76F-3DA3C8B3A323}" v="2" dt="2026-07-14T11:37:10.307"/>
   </p1510:revLst>
 </p1510:revInfo>
 </file>
@@ -141,7 +141,7 @@
   <pc:docChgLst>
     <pc:chgData name="chaitali patil" userId="93c03ccf1d40b7ec" providerId="LiveId" clId="{12F2214F-EB89-498D-9B46-BFD7F3C920F7}"/>
     <pc:docChg chg="custSel addSld modSld">
-      <pc:chgData name="chaitali patil" userId="93c03ccf1d40b7ec" providerId="LiveId" clId="{12F2214F-EB89-498D-9B46-BFD7F3C920F7}" dt="2026-07-13T00:22:00.279" v="614" actId="20577"/>
+      <pc:chgData name="chaitali patil" userId="93c03ccf1d40b7ec" providerId="LiveId" clId="{12F2214F-EB89-498D-9B46-BFD7F3C920F7}" dt="2026-07-14T09:41:13.235" v="720" actId="20577"/>
       <pc:docMkLst>
         <pc:docMk/>
       </pc:docMkLst>
@@ -161,13 +161,28 @@
         </pc:spChg>
       </pc:sldChg>
       <pc:sldChg chg="modSp mod">
-        <pc:chgData name="chaitali patil" userId="93c03ccf1d40b7ec" providerId="LiveId" clId="{12F2214F-EB89-498D-9B46-BFD7F3C920F7}" dt="2026-07-12T22:49:27.631" v="235" actId="20577"/>
+        <pc:chgData name="chaitali patil" userId="93c03ccf1d40b7ec" providerId="LiveId" clId="{12F2214F-EB89-498D-9B46-BFD7F3C920F7}" dt="2026-07-14T11:37:23.568" v="670" actId="20577"/>
+        <pc:sldMkLst>
+          <pc:docMk/>
+          <pc:sldMk cId="1396575391" sldId="257"/>
+        </pc:sldMkLst>
+        <pc:graphicFrameChg chg="mod modGraphic">
+          <ac:chgData name="chaitali patil" userId="93c03ccf1d40b7ec" providerId="LiveId" clId="{12F2214F-EB89-498D-9B46-BFD7F3C920F7}" dt="2026-07-14T11:37:23.568" v="670" actId="20577"/>
+          <ac:graphicFrameMkLst>
+            <pc:docMk/>
+            <pc:sldMk cId="1396575391" sldId="257"/>
+            <ac:graphicFrameMk id="5" creationId="{3B2092C1-6C97-5D76-936F-77DA06CEB174}"/>
+          </ac:graphicFrameMkLst>
+        </pc:graphicFrameChg>
+      </pc:sldChg>
+      <pc:sldChg chg="modSp mod">
+        <pc:chgData name="chaitali patil" userId="93c03ccf1d40b7ec" providerId="LiveId" clId="{12F2214F-EB89-498D-9B46-BFD7F3C920F7}" dt="2026-07-14T11:37:52.683" v="689" actId="20577"/>
         <pc:sldMkLst>
           <pc:docMk/>
           <pc:sldMk cId="1610684589" sldId="260"/>
         </pc:sldMkLst>
         <pc:graphicFrameChg chg="modGraphic">
-          <ac:chgData name="chaitali patil" userId="93c03ccf1d40b7ec" providerId="LiveId" clId="{12F2214F-EB89-498D-9B46-BFD7F3C920F7}" dt="2026-07-12T22:49:27.631" v="235" actId="20577"/>
+          <ac:chgData name="chaitali patil" userId="93c03ccf1d40b7ec" providerId="LiveId" clId="{12F2214F-EB89-498D-9B46-BFD7F3C920F7}" dt="2026-07-14T11:37:52.683" v="689" actId="20577"/>
           <ac:graphicFrameMkLst>
             <pc:docMk/>
             <pc:sldMk cId="1610684589" sldId="260"/>
@@ -176,13 +191,13 @@
         </pc:graphicFrameChg>
       </pc:sldChg>
       <pc:sldChg chg="addSp modSp new mod">
-        <pc:chgData name="chaitali patil" userId="93c03ccf1d40b7ec" providerId="LiveId" clId="{12F2214F-EB89-498D-9B46-BFD7F3C920F7}" dt="2026-07-12T23:09:13.708" v="581" actId="14100"/>
+        <pc:chgData name="chaitali patil" userId="93c03ccf1d40b7ec" providerId="LiveId" clId="{12F2214F-EB89-498D-9B46-BFD7F3C920F7}" dt="2026-07-14T09:41:13.235" v="720" actId="20577"/>
         <pc:sldMkLst>
           <pc:docMk/>
           <pc:sldMk cId="2297239741" sldId="274"/>
         </pc:sldMkLst>
         <pc:spChg chg="add mod">
-          <ac:chgData name="chaitali patil" userId="93c03ccf1d40b7ec" providerId="LiveId" clId="{12F2214F-EB89-498D-9B46-BFD7F3C920F7}" dt="2026-07-12T23:02:19.932" v="306" actId="1076"/>
+          <ac:chgData name="chaitali patil" userId="93c03ccf1d40b7ec" providerId="LiveId" clId="{12F2214F-EB89-498D-9B46-BFD7F3C920F7}" dt="2026-07-14T09:41:13.235" v="720" actId="20577"/>
           <ac:spMkLst>
             <pc:docMk/>
             <pc:sldMk cId="2297239741" sldId="274"/>
@@ -190,7 +205,7 @@
           </ac:spMkLst>
         </pc:spChg>
         <pc:graphicFrameChg chg="add mod modGraphic">
-          <ac:chgData name="chaitali patil" userId="93c03ccf1d40b7ec" providerId="LiveId" clId="{12F2214F-EB89-498D-9B46-BFD7F3C920F7}" dt="2026-07-12T23:09:13.708" v="581" actId="14100"/>
+          <ac:chgData name="chaitali patil" userId="93c03ccf1d40b7ec" providerId="LiveId" clId="{12F2214F-EB89-498D-9B46-BFD7F3C920F7}" dt="2026-07-14T11:38:03.088" v="708" actId="20577"/>
           <ac:graphicFrameMkLst>
             <pc:docMk/>
             <pc:sldMk cId="2297239741" sldId="274"/>
@@ -352,7 +367,7 @@
           <a:p>
             <a:fld id="{2A0FD183-B579-442F-AEDC-576E97AC8F49}" type="datetimeFigureOut">
               <a:rPr lang="en-IN" smtClean="0"/>
-              <a:t>13-07-2026</a:t>
+              <a:t>14-07-2026</a:t>
             </a:fld>
             <a:endParaRPr lang="en-IN"/>
           </a:p>
@@ -552,7 +567,7 @@
           <a:p>
             <a:fld id="{2A0FD183-B579-442F-AEDC-576E97AC8F49}" type="datetimeFigureOut">
               <a:rPr lang="en-IN" smtClean="0"/>
-              <a:t>13-07-2026</a:t>
+              <a:t>14-07-2026</a:t>
             </a:fld>
             <a:endParaRPr lang="en-IN"/>
           </a:p>
@@ -762,7 +777,7 @@
           <a:p>
             <a:fld id="{2A0FD183-B579-442F-AEDC-576E97AC8F49}" type="datetimeFigureOut">
               <a:rPr lang="en-IN" smtClean="0"/>
-              <a:t>13-07-2026</a:t>
+              <a:t>14-07-2026</a:t>
             </a:fld>
             <a:endParaRPr lang="en-IN"/>
           </a:p>
@@ -962,7 +977,7 @@
           <a:p>
             <a:fld id="{2A0FD183-B579-442F-AEDC-576E97AC8F49}" type="datetimeFigureOut">
               <a:rPr lang="en-IN" smtClean="0"/>
-              <a:t>13-07-2026</a:t>
+              <a:t>14-07-2026</a:t>
             </a:fld>
             <a:endParaRPr lang="en-IN"/>
           </a:p>
@@ -1238,7 +1253,7 @@
           <a:p>
             <a:fld id="{2A0FD183-B579-442F-AEDC-576E97AC8F49}" type="datetimeFigureOut">
               <a:rPr lang="en-IN" smtClean="0"/>
-              <a:t>13-07-2026</a:t>
+              <a:t>14-07-2026</a:t>
             </a:fld>
             <a:endParaRPr lang="en-IN"/>
           </a:p>
@@ -1506,7 +1521,7 @@
           <a:p>
             <a:fld id="{2A0FD183-B579-442F-AEDC-576E97AC8F49}" type="datetimeFigureOut">
               <a:rPr lang="en-IN" smtClean="0"/>
-              <a:t>13-07-2026</a:t>
+              <a:t>14-07-2026</a:t>
             </a:fld>
             <a:endParaRPr lang="en-IN"/>
           </a:p>
@@ -1921,7 +1936,7 @@
           <a:p>
             <a:fld id="{2A0FD183-B579-442F-AEDC-576E97AC8F49}" type="datetimeFigureOut">
               <a:rPr lang="en-IN" smtClean="0"/>
-              <a:t>13-07-2026</a:t>
+              <a:t>14-07-2026</a:t>
             </a:fld>
             <a:endParaRPr lang="en-IN"/>
           </a:p>
@@ -2063,7 +2078,7 @@
           <a:p>
             <a:fld id="{2A0FD183-B579-442F-AEDC-576E97AC8F49}" type="datetimeFigureOut">
               <a:rPr lang="en-IN" smtClean="0"/>
-              <a:t>13-07-2026</a:t>
+              <a:t>14-07-2026</a:t>
             </a:fld>
             <a:endParaRPr lang="en-IN"/>
           </a:p>
@@ -2176,7 +2191,7 @@
           <a:p>
             <a:fld id="{2A0FD183-B579-442F-AEDC-576E97AC8F49}" type="datetimeFigureOut">
               <a:rPr lang="en-IN" smtClean="0"/>
-              <a:t>13-07-2026</a:t>
+              <a:t>14-07-2026</a:t>
             </a:fld>
             <a:endParaRPr lang="en-IN"/>
           </a:p>
@@ -2489,7 +2504,7 @@
           <a:p>
             <a:fld id="{2A0FD183-B579-442F-AEDC-576E97AC8F49}" type="datetimeFigureOut">
               <a:rPr lang="en-IN" smtClean="0"/>
-              <a:t>13-07-2026</a:t>
+              <a:t>14-07-2026</a:t>
             </a:fld>
             <a:endParaRPr lang="en-IN"/>
           </a:p>
@@ -2778,7 +2793,7 @@
           <a:p>
             <a:fld id="{2A0FD183-B579-442F-AEDC-576E97AC8F49}" type="datetimeFigureOut">
               <a:rPr lang="en-IN" smtClean="0"/>
-              <a:t>13-07-2026</a:t>
+              <a:t>14-07-2026</a:t>
             </a:fld>
             <a:endParaRPr lang="en-IN"/>
           </a:p>
@@ -3021,7 +3036,7 @@
           <a:p>
             <a:fld id="{2A0FD183-B579-442F-AEDC-576E97AC8F49}" type="datetimeFigureOut">
               <a:rPr lang="en-IN" smtClean="0"/>
-              <a:t>13-07-2026</a:t>
+              <a:t>14-07-2026</a:t>
             </a:fld>
             <a:endParaRPr lang="en-IN"/>
           </a:p>
@@ -4379,7 +4394,7 @@
             <p:ph idx="1"/>
             <p:extLst>
               <p:ext uri="{D42A27DB-BD31-4B8C-83A1-F6EECF244321}">
-                <p14:modId xmlns:p14="http://schemas.microsoft.com/office/powerpoint/2010/main" val="2475322349"/>
+                <p14:modId xmlns:p14="http://schemas.microsoft.com/office/powerpoint/2010/main" val="1132943862"/>
               </p:ext>
             </p:extLst>
           </p:nvPr>
@@ -4624,7 +4639,7 @@
                     <a:p>
                       <a:r>
                         <a:rPr lang="en-US" dirty="0"/>
-                        <a:t>Dhanraj</a:t>
+                        <a:t>Harshwardhan</a:t>
                       </a:r>
                       <a:endParaRPr lang="en-IN" dirty="0"/>
                     </a:p>
@@ -4839,7 +4854,7 @@
           <p:nvPr>
             <p:extLst>
               <p:ext uri="{D42A27DB-BD31-4B8C-83A1-F6EECF244321}">
-                <p14:modId xmlns:p14="http://schemas.microsoft.com/office/powerpoint/2010/main" val="4204061373"/>
+                <p14:modId xmlns:p14="http://schemas.microsoft.com/office/powerpoint/2010/main" val="181300506"/>
               </p:ext>
             </p:extLst>
           </p:nvPr>
@@ -5130,8 +5145,8 @@
                     <a:lstStyle/>
                     <a:p>
                       <a:r>
-                        <a:rPr lang="en-US" dirty="0"/>
-                        <a:t>Harshwardhan</a:t>
+                        <a:rPr lang="en-US"/>
+                        <a:t>Dhanraj</a:t>
                       </a:r>
                       <a:endParaRPr lang="en-IN" dirty="0"/>
                     </a:p>
@@ -5262,7 +5277,7 @@
           <a:p>
             <a:r>
               <a:rPr lang="en-IN" sz="5400" dirty="0"/>
-              <a:t>Task Distribution to Developers</a:t>
+              <a:t>Task Distribution to QA</a:t>
             </a:r>
             <a:endParaRPr lang="en-IN" dirty="0"/>
           </a:p>
@@ -5356,14 +5371,14 @@
             <p:ph idx="1"/>
             <p:extLst>
               <p:ext uri="{D42A27DB-BD31-4B8C-83A1-F6EECF244321}">
-                <p14:modId xmlns:p14="http://schemas.microsoft.com/office/powerpoint/2010/main" val="2080327639"/>
+                <p14:modId xmlns:p14="http://schemas.microsoft.com/office/powerpoint/2010/main" val="284584966"/>
               </p:ext>
             </p:extLst>
           </p:nvPr>
         </p:nvGraphicFramePr>
         <p:xfrm>
           <a:off x="64168" y="1036805"/>
-          <a:ext cx="12005510" cy="6454511"/>
+          <a:ext cx="12005510" cy="6500125"/>
         </p:xfrm>
         <a:graphic>
           <a:graphicData uri="http://schemas.openxmlformats.org/drawingml/2006/table">
@@ -5504,14 +5519,29 @@
                     <a:bodyPr/>
                     <a:lstStyle/>
                     <a:p>
+                      <a:pPr marL="0" marR="0" lvl="0" indent="0" algn="l" defTabSz="914400" rtl="0" eaLnBrk="1" fontAlgn="auto" latinLnBrk="0" hangingPunct="1">
+                        <a:lnSpc>
+                          <a:spcPct val="100000"/>
+                        </a:lnSpc>
+                        <a:spcBef>
+                          <a:spcPts val="0"/>
+                        </a:spcBef>
+                        <a:spcAft>
+                          <a:spcPts val="0"/>
+                        </a:spcAft>
+                        <a:buClrTx/>
+                        <a:buSzTx/>
+                        <a:buFontTx/>
+                        <a:buNone/>
+                        <a:tabLst/>
+                        <a:defRPr/>
+                      </a:pPr>
                       <a:r>
                         <a:rPr lang="en-IN" sz="2800" dirty="0"/>
-                        <a:t>Dhanraj Shankar </a:t>
+                        <a:t>Harshwardhan Pandurang Patil</a:t>
                       </a:r>
-                      <a:r>
-                        <a:rPr lang="en-IN" sz="2800" dirty="0" err="1"/>
-                        <a:t>Jawale</a:t>
-                      </a:r>
+                    </a:p>
+                    <a:p>
                       <a:endParaRPr lang="en-IN" sz="2800" dirty="0"/>
                     </a:p>
                   </a:txBody>
@@ -5608,10 +5638,35 @@
                     <a:bodyPr/>
                     <a:lstStyle/>
                     <a:p>
+                      <a:pPr marL="0" marR="0" lvl="0" indent="0" algn="l" defTabSz="914400" rtl="0" eaLnBrk="1" fontAlgn="auto" latinLnBrk="0" hangingPunct="1">
+                        <a:lnSpc>
+                          <a:spcPct val="100000"/>
+                        </a:lnSpc>
+                        <a:spcBef>
+                          <a:spcPts val="0"/>
+                        </a:spcBef>
+                        <a:spcAft>
+                          <a:spcPts val="0"/>
+                        </a:spcAft>
+                        <a:buClrTx/>
+                        <a:buSzTx/>
+                        <a:buFontTx/>
+                        <a:buNone/>
+                        <a:tabLst/>
+                        <a:defRPr/>
+                      </a:pPr>
                       <a:r>
                         <a:rPr lang="en-IN" sz="2800" dirty="0"/>
-                        <a:t>Harshwardhan Pandurang Patil</a:t>
+                        <a:t>Dhanraj Shankar </a:t>
                       </a:r>
+                      <a:r>
+                        <a:rPr lang="en-IN" sz="2800" dirty="0" err="1"/>
+                        <a:t>Jawale</a:t>
+                      </a:r>
+                      <a:endParaRPr lang="en-IN" sz="2800" dirty="0"/>
+                    </a:p>
+                    <a:p>
+                      <a:endParaRPr lang="en-IN" sz="2800" dirty="0"/>
                     </a:p>
                   </a:txBody>
                   <a:tcPr/>

</xml_diff>